<commit_message>
docs: remove rubric language from submission
</commit_message>
<xml_diff>
--- a/competition/2026-08-15/submission/agentfit-submission.pptx
+++ b/competition/2026-08-15/submission/agentfit-submission.pptx
@@ -12782,7 +12782,7 @@
         <p:spPr>
           <a:xfrm>
             <a:off x="914400" y="5143500"/>
-            <a:ext cx="3672230" cy="160020"/>
+            <a:ext cx="3876141" cy="160020"/>
           </a:xfrm>
           <a:prstGeom prst="rect">
             <a:avLst/>
@@ -12814,7 +12814,7 @@
                 </a:solidFill>
                 <a:latin typeface="Noto Sans Mono CJK SC"/>
               </a:rPr>
-              <a:t>官方 8 字段契约 · 适用于元 Agent 与候选业务执行 Agent</a:t>
+              <a:t>完整 Identity 契约 · 适用于元 Agent 与候选业务执行 Agent</a:t>
             </a:r>
           </a:p>
         </p:txBody>
@@ -13152,7 +13152,7 @@
                 </a:solidFill>
                 <a:latin typeface="Noto Sans CJK SC"/>
               </a:rPr>
-              <a:t>七个 Skill、HTTP/MCP 等价工具与上下文 4 选 2。</a:t>
+              <a:t>七个 Skill、HTTP/MCP 等价工具、共享状态与 Trace。</a:t>
             </a:r>
           </a:p>
         </p:txBody>
@@ -13198,7 +13198,7 @@
                 </a:solidFill>
                 <a:latin typeface="Noto Sans CJK SC"/>
               </a:rPr>
-              <a:t>Skill 必选、HTTP/MCP 工具可选；上下文 4 选 2，不以 RAG 为主机制。均为设计契约。</a:t>
+              <a:t>Skill 表达可复用方法，HTTP/MCP 连接工具；Dossier 与 Trace 构成可审计上下文。均为设计契约。</a:t>
             </a:r>
           </a:p>
         </p:txBody>
@@ -14474,7 +14474,7 @@
         <p:spPr>
           <a:xfrm>
             <a:off x="8229600" y="3200400"/>
-            <a:ext cx="1360627" cy="160020"/>
+            <a:ext cx="1495958" cy="160020"/>
           </a:xfrm>
           <a:prstGeom prst="rect">
             <a:avLst/>
@@ -14506,7 +14506,7 @@
                 </a:solidFill>
                 <a:latin typeface="Noto Sans Mono CJK SC"/>
               </a:rPr>
-              <a:t>上下文能力 · 4 选 2</a:t>
+              <a:t>上下文机制 · 双事实源</a:t>
             </a:r>
           </a:p>
         </p:txBody>
@@ -14782,7 +14782,7 @@
                 </a:solidFill>
                 <a:latin typeface="Noto Sans CJK SC"/>
               </a:rPr>
-              <a:t>设计契约，非运行证据 · Skill 必选，MCP 可选</a:t>
+              <a:t>设计契约，非运行证据 · 能力、接口、状态与轨迹各有明确边界</a:t>
             </a:r>
           </a:p>
         </p:txBody>
@@ -24898,7 +24898,7 @@
                 </a:solidFill>
                 <a:latin typeface="Noto Sans CJK SC"/>
               </a:rPr>
-              <a:t>Skill 必选、HTTP/MCP 工具可选，所有候选使用同一契约。</a:t>
+              <a:t>所有候选使用同一能力、工具与接口契约。</a:t>
             </a:r>
           </a:p>
         </p:txBody>
@@ -31048,7 +31048,7 @@
                 </a:solidFill>
                 <a:latin typeface="Noto Sans Mono CJK SC"/>
               </a:rPr>
-              <a:t>共享状态 · 上下文 4 选 2</a:t>
+              <a:t>共享状态 · 项目事实源</a:t>
             </a:r>
           </a:p>
         </p:txBody>
@@ -31510,7 +31510,7 @@
                 </a:solidFill>
                 <a:latin typeface="Noto Sans CJK SC"/>
               </a:rPr>
-              <a:t>契约先行：Skill 必选、HTTP/MCP 工具可选、共享状态与 Trace 必在。</a:t>
+              <a:t>契约先行：Skill 定义方法，HTTP/MCP 连接工具，Dossier 与 Trace 保存状态和证据。</a:t>
             </a:r>
           </a:p>
         </p:txBody>

</xml_diff>

<commit_message>
docs: stabilize competition learning-loop narrative
</commit_message>
<xml_diff>
--- a/competition/2026-08-15/submission/agentfit-submission.pptx
+++ b/competition/2026-08-15/submission/agentfit-submission.pptx
@@ -4676,39 +4676,39 @@
         <p:spPr>
           <a:xfrm>
             <a:off x="685800" y="724204"/>
-            <a:ext cx="11036808" cy="439826"/>
-          </a:xfrm>
-          <a:prstGeom prst="rect">
-            <a:avLst/>
-          </a:prstGeom>
-          <a:noFill/>
-        </p:spPr>
-        <p:txBody>
-          <a:bodyPr wrap="square" lIns="0" tIns="0" rIns="0" bIns="0">
-            <a:spAutoFit/>
-          </a:bodyPr>
-          <a:lstStyle/>
-          <a:p>
-            <a:pPr marL="0" indent="0" algn="l">
-              <a:lnSpc>
-                <a:spcPts val="3470"/>
-              </a:lnSpc>
-              <a:spcBef>
-                <a:spcPts val="0"/>
-              </a:spcBef>
-              <a:spcAft>
-                <a:spcPts val="0"/>
-              </a:spcAft>
-              <a:buNone/>
-            </a:pPr>
-            <a:r>
-              <a:rPr b="1" sz="3150">
+            <a:ext cx="11036808" cy="314553"/>
+          </a:xfrm>
+          <a:prstGeom prst="rect">
+            <a:avLst/>
+          </a:prstGeom>
+          <a:noFill/>
+        </p:spPr>
+        <p:txBody>
+          <a:bodyPr wrap="square" lIns="0" tIns="0" rIns="0" bIns="0">
+            <a:spAutoFit/>
+          </a:bodyPr>
+          <a:lstStyle/>
+          <a:p>
+            <a:pPr marL="0" indent="0" algn="l">
+              <a:lnSpc>
+                <a:spcPts val="2480"/>
+              </a:lnSpc>
+              <a:spcBef>
+                <a:spcPts val="0"/>
+              </a:spcBef>
+              <a:spcAft>
+                <a:spcPts val="0"/>
+              </a:spcAft>
+              <a:buNone/>
+            </a:pPr>
+            <a:r>
+              <a:rPr b="1" sz="2250">
                 <a:solidFill>
                   <a:srgbClr val="102A43"/>
                 </a:solidFill>
                 <a:latin typeface="Noto Sans CJK SC"/>
               </a:rPr>
-              <a:t>交付 AgentSolutionPackage 与五种合法结果。</a:t>
+              <a:t>交付的不是一张架构图，而是可复现的 AgentSolutionPackage。</a:t>
             </a:r>
           </a:p>
         </p:txBody>
@@ -4754,7 +4754,7 @@
                 </a:solidFill>
                 <a:latin typeface="Noto Sans CJK SC"/>
               </a:rPr>
-              <a:t>交付的是“方案 + 证据 + 运行边界”；结果可以自动化，也可以有证据地保留人工或拒绝。</a:t>
+              <a:t>方案版本、案例集、实验历史、Trace、失败记录与运行边界共同支撑五种合法结果。</a:t>
             </a:r>
           </a:p>
         </p:txBody>
@@ -5032,7 +5032,7 @@
                 </a:solidFill>
                 <a:latin typeface="Noto Sans CJK SC"/>
               </a:rPr>
-              <a:t>架构图 + Tool / Skill / MCP / Memory / 模型 / 拓扑</a:t>
+              <a:t>方案版本 + Tool / Skill / MCP / Memory / 模型 / 拓扑</a:t>
             </a:r>
           </a:p>
         </p:txBody>
@@ -5218,7 +5218,7 @@
                 </a:solidFill>
                 <a:latin typeface="Noto Sans CJK SC"/>
               </a:rPr>
-              <a:t>版本化案例 + Episode + Trace + 失败记录</a:t>
+              <a:t>案例版本 + 方案版本 + 实验历史 + Trace</a:t>
             </a:r>
           </a:p>
         </p:txBody>
@@ -23796,39 +23796,39 @@
         <p:spPr>
           <a:xfrm>
             <a:off x="685800" y="724204"/>
-            <a:ext cx="11036808" cy="282549"/>
-          </a:xfrm>
-          <a:prstGeom prst="rect">
-            <a:avLst/>
-          </a:prstGeom>
-          <a:noFill/>
-        </p:spPr>
-        <p:txBody>
-          <a:bodyPr wrap="square" lIns="0" tIns="0" rIns="0" bIns="0">
-            <a:spAutoFit/>
-          </a:bodyPr>
-          <a:lstStyle/>
-          <a:p>
-            <a:pPr marL="0" indent="0" algn="l">
-              <a:lnSpc>
-                <a:spcPts val="2230"/>
-              </a:lnSpc>
-              <a:spcBef>
-                <a:spcPts val="0"/>
-              </a:spcBef>
-              <a:spcAft>
-                <a:spcPts val="0"/>
-              </a:spcAft>
-              <a:buNone/>
-            </a:pPr>
-            <a:r>
-              <a:rPr b="1" sz="2020">
+            <a:ext cx="11036808" cy="314553"/>
+          </a:xfrm>
+          <a:prstGeom prst="rect">
+            <a:avLst/>
+          </a:prstGeom>
+          <a:noFill/>
+        </p:spPr>
+        <p:txBody>
+          <a:bodyPr wrap="square" lIns="0" tIns="0" rIns="0" bIns="0">
+            <a:spAutoFit/>
+          </a:bodyPr>
+          <a:lstStyle/>
+          <a:p>
+            <a:pPr marL="0" indent="0" algn="l">
+              <a:lnSpc>
+                <a:spcPts val="2480"/>
+              </a:lnSpc>
+              <a:spcBef>
+                <a:spcPts val="0"/>
+              </a:spcBef>
+              <a:spcAft>
+                <a:spcPts val="0"/>
+              </a:spcAft>
+              <a:buNone/>
+            </a:pPr>
+            <a:r>
+              <a:rPr b="1" sz="2250">
                 <a:solidFill>
                   <a:srgbClr val="102A43"/>
                 </a:solidFill>
                 <a:latin typeface="Noto Sans CJK SC"/>
               </a:rPr>
-              <a:t>完整方案空间：工具、Skill、MCP、Memory、模型、Agent 拓扑与 Human 边界都是变量。</a:t>
+              <a:t>调整对象是完整 Agent Solution，而不是 Agent 数量。</a:t>
             </a:r>
           </a:p>
         </p:txBody>
@@ -23874,7 +23874,7 @@
                 </a:solidFill>
                 <a:latin typeface="Noto Sans CJK SC"/>
               </a:rPr>
-              <a:t>不是只选 Agent 数量；每一维都从最小配置开始，只有失败证据足够时才增加复杂度。</a:t>
+              <a:t>Tool、Skill、MCP、Memory、模型、Agent 拓扑与 Human 边界都是变量。</a:t>
             </a:r>
           </a:p>
         </p:txBody>
@@ -23980,7 +23980,7 @@
         <p:spPr>
           <a:xfrm>
             <a:off x="914400" y="2342692"/>
-            <a:ext cx="1632204" cy="160020"/>
+            <a:ext cx="1224381" cy="160020"/>
           </a:xfrm>
           <a:prstGeom prst="rect">
             <a:avLst/>
@@ -24012,7 +24012,7 @@
                 </a:solidFill>
                 <a:latin typeface="Noto Sans Mono CJK SC"/>
               </a:rPr>
-              <a:t>六个可独立调整的方案维度</a:t>
+              <a:t>六个非拓扑方案维度</a:t>
             </a:r>
           </a:p>
         </p:txBody>
@@ -25600,7 +25600,7 @@
                 </a:solidFill>
                 <a:latin typeface="Noto Sans CJK SC"/>
               </a:rPr>
-              <a:t>七个维度属于同一搜索空间；OpsPilot 的 4 Worker + 1 Leader 只是 Agent 拓扑中 C2 的一个实例。</a:t>
+              <a:t>SIMPLE FIRST = 复杂度控制：七个维度属于同一搜索空间；只有失败证据证明有价值，才增加一维。</a:t>
             </a:r>
           </a:p>
         </p:txBody>
@@ -25814,39 +25814,39 @@
         <p:spPr>
           <a:xfrm>
             <a:off x="685800" y="724204"/>
-            <a:ext cx="11036808" cy="617220"/>
-          </a:xfrm>
-          <a:prstGeom prst="rect">
-            <a:avLst/>
-          </a:prstGeom>
-          <a:noFill/>
-        </p:spPr>
-        <p:txBody>
-          <a:bodyPr wrap="square" lIns="0" tIns="0" rIns="0" bIns="0">
-            <a:spAutoFit/>
-          </a:bodyPr>
-          <a:lstStyle/>
-          <a:p>
-            <a:pPr marL="0" indent="0" algn="l">
-              <a:lnSpc>
-                <a:spcPts val="2430"/>
-              </a:lnSpc>
-              <a:spcBef>
-                <a:spcPts val="0"/>
-              </a:spcBef>
-              <a:spcAft>
-                <a:spcPts val="0"/>
-              </a:spcAft>
-              <a:buNone/>
-            </a:pPr>
-            <a:r>
-              <a:rPr b="1" sz="2250">
+            <a:ext cx="11036808" cy="288036"/>
+          </a:xfrm>
+          <a:prstGeom prst="rect">
+            <a:avLst/>
+          </a:prstGeom>
+          <a:noFill/>
+        </p:spPr>
+        <p:txBody>
+          <a:bodyPr wrap="square" lIns="0" tIns="0" rIns="0" bIns="0">
+            <a:spAutoFit/>
+          </a:bodyPr>
+          <a:lstStyle/>
+          <a:p>
+            <a:pPr marL="0" indent="0" algn="l">
+              <a:lnSpc>
+                <a:spcPts val="2270"/>
+              </a:lnSpc>
+              <a:spcBef>
+                <a:spcPts val="0"/>
+              </a:spcBef>
+              <a:spcAft>
+                <a:spcPts val="0"/>
+              </a:spcAft>
+              <a:buNone/>
+            </a:pPr>
+            <a:r>
+              <a:rPr b="1" sz="2100">
                 <a:solidFill>
                   <a:srgbClr val="102A43"/>
                 </a:solidFill>
                 <a:latin typeface="Noto Sans CJK SC"/>
               </a:rPr>
-              <a:t>五阶段闭环：定义案例与验收、构建最小候选、运行并测量、分析并调整、验证并停止。</a:t>
+              <a:t>五阶段闭环：把机器学习的工程纪律带入 Agent 方案设计。</a:t>
             </a:r>
           </a:p>
         </p:txBody>
@@ -25892,7 +25892,7 @@
                 </a:solidFill>
                 <a:latin typeface="Noto Sans CJK SC"/>
               </a:rPr>
-              <a:t>同一预算与门禁下由简入繁；未通过才调整，通过新案例且无新增价值就停止。</a:t>
+              <a:t>借鉴样本构建、批量试验、误差分析和验证停止；调整的不是模型权重，而是完整 Agent Solution。</a:t>
             </a:r>
           </a:p>
         </p:txBody>
@@ -26120,7 +26120,7 @@
                 </a:solidFill>
                 <a:latin typeface="Noto Sans CJK SC"/>
               </a:rPr>
-              <a:t>定义案例与验收</a:t>
+              <a:t>样本工程</a:t>
             </a:r>
           </a:p>
         </p:txBody>
@@ -26166,7 +26166,7 @@
                 </a:solidFill>
                 <a:latin typeface="Noto Sans CJK SC"/>
               </a:rPr>
-              <a:t>冻结代表案例、优先级、预算与 Human 门禁。</a:t>
+              <a:t>冻结代表案例、用户目标、预算与 Human 门禁。</a:t>
             </a:r>
           </a:p>
         </p:txBody>
@@ -26352,7 +26352,7 @@
                 </a:solidFill>
                 <a:latin typeface="Noto Sans CJK SC"/>
               </a:rPr>
-              <a:t>构建最小候选</a:t>
+              <a:t>最小方案假设</a:t>
             </a:r>
           </a:p>
         </p:txBody>
@@ -26584,7 +26584,7 @@
                 </a:solidFill>
                 <a:latin typeface="Noto Sans CJK SC"/>
               </a:rPr>
-              <a:t>运行并测量</a:t>
+              <a:t>批量试验</a:t>
             </a:r>
           </a:p>
         </p:txBody>
@@ -26816,7 +26816,7 @@
                 </a:solidFill>
                 <a:latin typeface="Noto Sans CJK SC"/>
               </a:rPr>
-              <a:t>分析并调整</a:t>
+              <a:t>Trace 误差分析</a:t>
             </a:r>
           </a:p>
         </p:txBody>
@@ -26829,39 +26829,85 @@
         </p:nvSpPr>
         <p:spPr>
           <a:xfrm>
-            <a:off x="7315200" y="3219602"/>
-            <a:ext cx="1787652" cy="617220"/>
-          </a:xfrm>
-          <a:prstGeom prst="rect">
-            <a:avLst/>
-          </a:prstGeom>
-          <a:noFill/>
-        </p:spPr>
-        <p:txBody>
-          <a:bodyPr wrap="square" lIns="0" tIns="0" rIns="0" bIns="0">
-            <a:spAutoFit/>
-          </a:bodyPr>
-          <a:lstStyle/>
-          <a:p>
-            <a:pPr marL="0" indent="0" algn="l">
-              <a:lnSpc>
-                <a:spcPts val="1620"/>
-              </a:lnSpc>
-              <a:spcBef>
-                <a:spcPts val="0"/>
-              </a:spcBef>
-              <a:spcAft>
-                <a:spcPts val="0"/>
-              </a:spcAft>
-              <a:buNone/>
-            </a:pPr>
-            <a:r>
-              <a:rPr sz="1200">
+            <a:off x="7315200" y="3181197"/>
+            <a:ext cx="1787652" cy="357530"/>
+          </a:xfrm>
+          <a:prstGeom prst="rect">
+            <a:avLst/>
+          </a:prstGeom>
+          <a:noFill/>
+        </p:spPr>
+        <p:txBody>
+          <a:bodyPr wrap="square" lIns="0" tIns="0" rIns="0" bIns="0">
+            <a:spAutoFit/>
+          </a:bodyPr>
+          <a:lstStyle/>
+          <a:p>
+            <a:pPr marL="0" indent="0" algn="l">
+              <a:lnSpc>
+                <a:spcPts val="1410"/>
+              </a:lnSpc>
+              <a:spcBef>
+                <a:spcPts val="0"/>
+              </a:spcBef>
+              <a:spcAft>
+                <a:spcPts val="0"/>
+              </a:spcAft>
+              <a:buNone/>
+            </a:pPr>
+            <a:r>
+              <a:rPr sz="1120">
                 <a:solidFill>
                   <a:srgbClr val="53697C"/>
                 </a:solidFill>
                 <a:latin typeface="Noto Sans CJK SC"/>
               </a:rPr>
+              <a:t>指标说明错多少，Trace 定位错在哪里。</a:t>
+            </a:r>
+          </a:p>
+        </p:txBody>
+      </p:sp>
+      <p:sp>
+        <p:nvSpPr>
+          <p:cNvPr id="27" name="h2p-6-text-26"/>
+          <p:cNvSpPr txBox="1"/>
+          <p:nvPr/>
+        </p:nvSpPr>
+        <p:spPr>
+          <a:xfrm>
+            <a:off x="7315200" y="3696004"/>
+            <a:ext cx="1787652" cy="357530"/>
+          </a:xfrm>
+          <a:prstGeom prst="rect">
+            <a:avLst/>
+          </a:prstGeom>
+          <a:noFill/>
+        </p:spPr>
+        <p:txBody>
+          <a:bodyPr wrap="square" lIns="0" tIns="0" rIns="0" bIns="0">
+            <a:spAutoFit/>
+          </a:bodyPr>
+          <a:lstStyle/>
+          <a:p>
+            <a:pPr marL="0" indent="0" algn="l">
+              <a:lnSpc>
+                <a:spcPts val="1410"/>
+              </a:lnSpc>
+              <a:spcBef>
+                <a:spcPts val="0"/>
+              </a:spcBef>
+              <a:spcAft>
+                <a:spcPts val="0"/>
+              </a:spcAft>
+              <a:buNone/>
+            </a:pPr>
+            <a:r>
+              <a:rPr sz="1120">
+                <a:solidFill>
+                  <a:srgbClr val="53697C"/>
+                </a:solidFill>
+                <a:latin typeface="Noto Sans CJK SC"/>
+              </a:rPr>
               <a:t>按失败模式调整七维方案；不越过 Human 门禁。</a:t>
             </a:r>
           </a:p>
@@ -26869,7 +26915,7 @@
       </p:sp>
       <p:sp>
         <p:nvSpPr>
-          <p:cNvPr id="27" name="h2p-6-text-26"/>
+          <p:cNvPr id="28" name="h2p-6-text-27"/>
           <p:cNvSpPr txBox="1"/>
           <p:nvPr/>
         </p:nvSpPr>
@@ -26915,7 +26961,7 @@
       </p:sp>
       <p:sp>
         <p:nvSpPr>
-          <p:cNvPr id="28" name="h2p-6-box-27"/>
+          <p:cNvPr id="29" name="h2p-6-box-28"/>
           <p:cNvSpPr/>
           <p:nvPr/>
         </p:nvSpPr>
@@ -26963,7 +27009,7 @@
       </p:sp>
       <p:sp>
         <p:nvSpPr>
-          <p:cNvPr id="29" name="h2p-6-text-28"/>
+          <p:cNvPr id="30" name="h2p-6-text-29"/>
           <p:cNvSpPr txBox="1"/>
           <p:nvPr/>
         </p:nvSpPr>
@@ -27009,53 +27055,53 @@
       </p:sp>
       <p:sp>
         <p:nvSpPr>
-          <p:cNvPr id="30" name="h2p-6-text-29"/>
+          <p:cNvPr id="31" name="h2p-6-text-30"/>
           <p:cNvSpPr txBox="1"/>
           <p:nvPr/>
         </p:nvSpPr>
         <p:spPr>
           <a:xfrm>
             <a:off x="9562795" y="2819095"/>
-            <a:ext cx="1787652" cy="213055"/>
-          </a:xfrm>
-          <a:prstGeom prst="rect">
-            <a:avLst/>
-          </a:prstGeom>
-          <a:noFill/>
-        </p:spPr>
-        <p:txBody>
-          <a:bodyPr wrap="square" lIns="0" tIns="0" rIns="0" bIns="0">
-            <a:spAutoFit/>
-          </a:bodyPr>
-          <a:lstStyle/>
-          <a:p>
-            <a:pPr marL="0" indent="0" algn="l">
-              <a:lnSpc>
-                <a:spcPts val="1680"/>
-              </a:lnSpc>
-              <a:spcBef>
-                <a:spcPts val="0"/>
-              </a:spcBef>
-              <a:spcAft>
-                <a:spcPts val="0"/>
-              </a:spcAft>
-              <a:buNone/>
-            </a:pPr>
-            <a:r>
-              <a:rPr b="1" sz="1420">
+            <a:ext cx="1787652" cy="202082"/>
+          </a:xfrm>
+          <a:prstGeom prst="rect">
+            <a:avLst/>
+          </a:prstGeom>
+          <a:noFill/>
+        </p:spPr>
+        <p:txBody>
+          <a:bodyPr wrap="square" lIns="0" tIns="0" rIns="0" bIns="0">
+            <a:spAutoFit/>
+          </a:bodyPr>
+          <a:lstStyle/>
+          <a:p>
+            <a:pPr marL="0" indent="0" algn="l">
+              <a:lnSpc>
+                <a:spcPts val="1590"/>
+              </a:lnSpc>
+              <a:spcBef>
+                <a:spcPts val="0"/>
+              </a:spcBef>
+              <a:spcAft>
+                <a:spcPts val="0"/>
+              </a:spcAft>
+              <a:buNone/>
+            </a:pPr>
+            <a:r>
+              <a:rPr b="1" sz="1350">
                 <a:solidFill>
                   <a:srgbClr val="102A43"/>
                 </a:solidFill>
                 <a:latin typeface="Noto Sans CJK SC"/>
               </a:rPr>
-              <a:t>验证并停止</a:t>
-            </a:r>
-          </a:p>
-        </p:txBody>
-      </p:sp>
-      <p:sp>
-        <p:nvSpPr>
-          <p:cNvPr id="31" name="h2p-6-text-30"/>
+              <a:t>新案例验证 / 停止</a:t>
+            </a:r>
+          </a:p>
+        </p:txBody>
+      </p:sp>
+      <p:sp>
+        <p:nvSpPr>
+          <p:cNvPr id="32" name="h2p-6-text-31"/>
           <p:cNvSpPr txBox="1"/>
           <p:nvPr/>
         </p:nvSpPr>
@@ -27101,7 +27147,7 @@
       </p:sp>
       <p:sp>
         <p:nvSpPr>
-          <p:cNvPr id="32" name="h2p-6-text-31"/>
+          <p:cNvPr id="33" name="h2p-6-text-32"/>
           <p:cNvSpPr txBox="1"/>
           <p:nvPr/>
         </p:nvSpPr>
@@ -27147,7 +27193,7 @@
       </p:sp>
       <p:sp>
         <p:nvSpPr>
-          <p:cNvPr id="33" name="h2p-6-box-32"/>
+          <p:cNvPr id="34" name="h2p-6-box-33"/>
           <p:cNvSpPr/>
           <p:nvPr/>
         </p:nvSpPr>
@@ -27195,7 +27241,7 @@
       </p:sp>
       <p:sp>
         <p:nvSpPr>
-          <p:cNvPr id="34" name="h2p-6-text-33"/>
+          <p:cNvPr id="35" name="h2p-6-text-34"/>
           <p:cNvSpPr txBox="1"/>
           <p:nvPr/>
         </p:nvSpPr>
@@ -27241,7 +27287,7 @@
       </p:sp>
       <p:sp>
         <p:nvSpPr>
-          <p:cNvPr id="35" name="h2p-6-text-34"/>
+          <p:cNvPr id="36" name="h2p-6-text-35"/>
           <p:cNvSpPr txBox="1"/>
           <p:nvPr/>
         </p:nvSpPr>
@@ -27296,7 +27342,7 @@
       </p:sp>
       <p:sp>
         <p:nvSpPr>
-          <p:cNvPr id="36" name="h2p-6-box-35"/>
+          <p:cNvPr id="37" name="h2p-6-box-36"/>
           <p:cNvSpPr/>
           <p:nvPr/>
         </p:nvSpPr>
@@ -27344,7 +27390,7 @@
       </p:sp>
       <p:sp>
         <p:nvSpPr>
-          <p:cNvPr id="37" name="h2p-6-text-36"/>
+          <p:cNvPr id="38" name="h2p-6-text-37"/>
           <p:cNvSpPr txBox="1"/>
           <p:nvPr/>
         </p:nvSpPr>
@@ -27390,7 +27436,7 @@
       </p:sp>
       <p:sp>
         <p:nvSpPr>
-          <p:cNvPr id="38" name="h2p-6-box-37"/>
+          <p:cNvPr id="39" name="h2p-6-box-38"/>
           <p:cNvSpPr/>
           <p:nvPr/>
         </p:nvSpPr>
@@ -27438,7 +27484,7 @@
       </p:sp>
       <p:sp>
         <p:nvSpPr>
-          <p:cNvPr id="39" name="h2p-6-text-38"/>
+          <p:cNvPr id="40" name="h2p-6-text-39"/>
           <p:cNvSpPr txBox="1"/>
           <p:nvPr/>
         </p:nvSpPr>
@@ -27484,7 +27530,7 @@
       </p:sp>
       <p:sp>
         <p:nvSpPr>
-          <p:cNvPr id="40" name="h2p-6-box-39"/>
+          <p:cNvPr id="41" name="h2p-6-box-40"/>
           <p:cNvSpPr/>
           <p:nvPr/>
         </p:nvSpPr>
@@ -27532,7 +27578,7 @@
       </p:sp>
       <p:sp>
         <p:nvSpPr>
-          <p:cNvPr id="41" name="h2p-6-text-40"/>
+          <p:cNvPr id="42" name="h2p-6-text-41"/>
           <p:cNvSpPr txBox="1"/>
           <p:nvPr/>
         </p:nvSpPr>
@@ -27578,7 +27624,7 @@
       </p:sp>
       <p:sp>
         <p:nvSpPr>
-          <p:cNvPr id="42" name="h2p-6-box-41"/>
+          <p:cNvPr id="43" name="h2p-6-box-42"/>
           <p:cNvSpPr/>
           <p:nvPr/>
         </p:nvSpPr>
@@ -27626,7 +27672,7 @@
       </p:sp>
       <p:sp>
         <p:nvSpPr>
-          <p:cNvPr id="43" name="h2p-6-text-42"/>
+          <p:cNvPr id="44" name="h2p-6-text-43"/>
           <p:cNvSpPr txBox="1"/>
           <p:nvPr/>
         </p:nvSpPr>
@@ -27672,7 +27718,7 @@
       </p:sp>
       <p:sp>
         <p:nvSpPr>
-          <p:cNvPr id="44" name="h2p-6-box-43"/>
+          <p:cNvPr id="45" name="h2p-6-box-44"/>
           <p:cNvSpPr/>
           <p:nvPr/>
         </p:nvSpPr>
@@ -27720,7 +27766,7 @@
       </p:sp>
       <p:sp>
         <p:nvSpPr>
-          <p:cNvPr id="45" name="h2p-6-text-44"/>
+          <p:cNvPr id="46" name="h2p-6-text-45"/>
           <p:cNvSpPr txBox="1"/>
           <p:nvPr/>
         </p:nvSpPr>
@@ -27766,7 +27812,7 @@
       </p:sp>
       <p:sp>
         <p:nvSpPr>
-          <p:cNvPr id="46" name="h2p-6-text-45"/>
+          <p:cNvPr id="47" name="h2p-6-text-46"/>
           <p:cNvSpPr txBox="1"/>
           <p:nvPr/>
         </p:nvSpPr>
@@ -27812,7 +27858,7 @@
       </p:sp>
       <p:sp>
         <p:nvSpPr>
-          <p:cNvPr id="47" name="h2p-6-text-46"/>
+          <p:cNvPr id="48" name="h2p-6-text-47"/>
           <p:cNvSpPr txBox="1"/>
           <p:nvPr/>
         </p:nvSpPr>
@@ -27858,7 +27904,7 @@
       </p:sp>
       <p:sp>
         <p:nvSpPr>
-          <p:cNvPr id="48" name="h2p-6-text-47"/>
+          <p:cNvPr id="49" name="h2p-6-text-48"/>
           <p:cNvSpPr txBox="1"/>
           <p:nvPr/>
         </p:nvSpPr>
@@ -28019,39 +28065,39 @@
         <p:spPr>
           <a:xfrm>
             <a:off x="685800" y="724204"/>
-            <a:ext cx="11036808" cy="314553"/>
-          </a:xfrm>
-          <a:prstGeom prst="rect">
-            <a:avLst/>
-          </a:prstGeom>
-          <a:noFill/>
-        </p:spPr>
-        <p:txBody>
-          <a:bodyPr wrap="square" lIns="0" tIns="0" rIns="0" bIns="0">
-            <a:spAutoFit/>
-          </a:bodyPr>
-          <a:lstStyle/>
-          <a:p>
-            <a:pPr marL="0" indent="0" algn="l">
-              <a:lnSpc>
-                <a:spcPts val="2480"/>
-              </a:lnSpc>
-              <a:spcBef>
-                <a:spcPts val="0"/>
-              </a:spcBef>
-              <a:spcAft>
-                <a:spcPts val="0"/>
-              </a:spcAft>
-              <a:buNone/>
-            </a:pPr>
-            <a:r>
-              <a:rPr b="1" sz="2250">
+            <a:ext cx="11036808" cy="272491"/>
+          </a:xfrm>
+          <a:prstGeom prst="rect">
+            <a:avLst/>
+          </a:prstGeom>
+          <a:noFill/>
+        </p:spPr>
+        <p:txBody>
+          <a:bodyPr wrap="square" lIns="0" tIns="0" rIns="0" bIns="0">
+            <a:spAutoFit/>
+          </a:bodyPr>
+          <a:lstStyle/>
+          <a:p>
+            <a:pPr marL="0" indent="0" algn="l">
+              <a:lnSpc>
+                <a:spcPts val="2150"/>
+              </a:lnSpc>
+              <a:spcBef>
+                <a:spcPts val="0"/>
+              </a:spcBef>
+              <a:spcAft>
+                <a:spcPts val="0"/>
+              </a:spcAft>
+              <a:buNone/>
+            </a:pPr>
+            <a:r>
+              <a:rPr b="1" sz="1950">
                 <a:solidFill>
                   <a:srgbClr val="102A43"/>
                 </a:solidFill>
                 <a:latin typeface="Noto Sans CJK SC"/>
               </a:rPr>
-              <a:t>五个元 Agent 完成方案闭环，区别于候选业务执行 Agent。</a:t>
+              <a:t>五个元 Agent 组成 AgentFit Learning Loop，分别负责目标、样本、方案、实验与诊断。</a:t>
             </a:r>
           </a:p>
         </p:txBody>
@@ -28097,7 +28143,7 @@
                 </a:solidFill>
                 <a:latin typeface="Noto Sans CJK SC"/>
               </a:rPr>
-              <a:t>五个固定身份共同覆盖闭环，并在阶段之间交接责任；候选内部的业务执行 Agent 是被设计对象。</a:t>
+              <a:t>五个固定身份共同覆盖闭环并交接责任；它们不是候选中的业务执行 Agent，而是一条可审计的方案工程流水线。</a:t>
             </a:r>
           </a:p>
         </p:txBody>
@@ -28400,7 +28446,7 @@
                 </a:solidFill>
                 <a:latin typeface="Noto Sans Mono CJK SC"/>
               </a:rPr>
-              <a:t>定义目标 / 决定停止</a:t>
+              <a:t>目标 / 停止控制</a:t>
             </a:r>
           </a:p>
         </p:txBody>
@@ -28632,7 +28678,7 @@
                 </a:solidFill>
                 <a:latin typeface="Noto Sans Mono CJK SC"/>
               </a:rPr>
-              <a:t>定义案例与验收</a:t>
+              <a:t>业务理解 / 样本工程</a:t>
             </a:r>
           </a:p>
         </p:txBody>
@@ -28864,7 +28910,7 @@
                 </a:solidFill>
                 <a:latin typeface="Noto Sans Mono CJK SC"/>
               </a:rPr>
-              <a:t>构建 / 调整候选</a:t>
+              <a:t>方案建模 / 结构选择</a:t>
             </a:r>
           </a:p>
         </p:txBody>
@@ -29096,7 +29142,7 @@
                 </a:solidFill>
                 <a:latin typeface="Noto Sans Mono CJK SC"/>
               </a:rPr>
-              <a:t>运行并测量</a:t>
+              <a:t>批量试验 / 指标采集</a:t>
             </a:r>
           </a:p>
         </p:txBody>
@@ -29328,7 +29374,7 @@
                 </a:solidFill>
                 <a:latin typeface="Noto Sans Mono CJK SC"/>
               </a:rPr>
-              <a:t>分析证据 / 独立审计</a:t>
+              <a:t>误差分析 / 治理审计</a:t>
             </a:r>
           </a:p>
         </p:txBody>

</xml_diff>